<commit_message>
docs: finalize presentation notes and evidence links
</commit_message>
<xml_diff>
--- a/docs/informe-grupo05/entrega/Grupo_05_Presentacion_Consolidada.pptx
+++ b/docs/informe-grupo05/entrega/Grupo_05_Presentacion_Consolidada.pptx
@@ -2,18 +2,18 @@
 <file path=ppt/presentation.xml><?xml version="1.0" encoding="utf-8"?>
 <p:presentation xmlns:p="http://schemas.openxmlformats.org/presentationml/2006/main">
   <p:sldMasterIdLst>
-    <p:sldMasterId xmlns:r="http://schemas.openxmlformats.org/officeDocument/2006/relationships" id="2147483648" r:id="R2a1cbf28fadb4497"/>
+    <p:sldMasterId xmlns:r="http://schemas.openxmlformats.org/officeDocument/2006/relationships" id="2147483648" r:id="R411a77d6186e45f6"/>
   </p:sldMasterIdLst>
   <p:notesMasterIdLst>
-    <p:notesMasterId xmlns:r="http://schemas.openxmlformats.org/officeDocument/2006/relationships" r:id="R420d2b0611e3435f"/>
+    <p:notesMasterId xmlns:r="http://schemas.openxmlformats.org/officeDocument/2006/relationships" r:id="Rcf14ae43176c41fa"/>
   </p:notesMasterIdLst>
   <p:sldIdLst>
-    <p:sldId xmlns:r="http://schemas.openxmlformats.org/officeDocument/2006/relationships" id="256" r:id="R3517378b9a414267"/>
-    <p:sldId xmlns:r="http://schemas.openxmlformats.org/officeDocument/2006/relationships" id="257" r:id="R52427cc93762407a"/>
-    <p:sldId xmlns:r="http://schemas.openxmlformats.org/officeDocument/2006/relationships" id="258" r:id="Ref9a792b0f0849fc"/>
-    <p:sldId xmlns:r="http://schemas.openxmlformats.org/officeDocument/2006/relationships" id="259" r:id="Rd1d3ef5c8eb64114"/>
-    <p:sldId xmlns:r="http://schemas.openxmlformats.org/officeDocument/2006/relationships" id="260" r:id="Rb7237bcfcd174500"/>
-    <p:sldId xmlns:r="http://schemas.openxmlformats.org/officeDocument/2006/relationships" id="261" r:id="R5fcb7563e07b45f7"/>
+    <p:sldId xmlns:r="http://schemas.openxmlformats.org/officeDocument/2006/relationships" id="256" r:id="R4a080ef3a0ad4f56"/>
+    <p:sldId xmlns:r="http://schemas.openxmlformats.org/officeDocument/2006/relationships" id="257" r:id="R2f2bb1d6a2524126"/>
+    <p:sldId xmlns:r="http://schemas.openxmlformats.org/officeDocument/2006/relationships" id="258" r:id="R559f313cbcd045ed"/>
+    <p:sldId xmlns:r="http://schemas.openxmlformats.org/officeDocument/2006/relationships" id="259" r:id="Ra7ff5e58ac1f4fd3"/>
+    <p:sldId xmlns:r="http://schemas.openxmlformats.org/officeDocument/2006/relationships" id="260" r:id="Rd336e4410c0c40ff"/>
+    <p:sldId xmlns:r="http://schemas.openxmlformats.org/officeDocument/2006/relationships" id="261" r:id="Rec6551ebd6cb488b"/>
   </p:sldIdLst>
   <p:sldSz cx="12192000" cy="6858000"/>
   <p:notesSz cx="6858000" cy="9144000"/>
@@ -447,7 +447,7 @@
           <a:lstStyle xmlns:a="http://schemas.openxmlformats.org/drawingml/2006/main"/>
           <a:p xmlns:a="http://schemas.openxmlformats.org/drawingml/2006/main">
             <a:r>
-              <a:t>0:00–1:30 (90 s). Propuesta: Benetucci Ignacio. Introducción (15 s): siete recursos, análisis estático, nunca ejecutamos muestras. F001 es una DLL aunque el nombre histórico termine en .exe; F002 es un ejecutable. Verificamos SHA-256, SHA-1, MD5 y tamaño contra VT: 47 detecciones cada uno. RAT significa troyano de acceso remoto; un atacante podría acceder a información o alterar el equipo, pero no observamos esas acciones. ValleyRAT viene de motores y reportes de terceros. Conclusión: maliciosos con confianza alta en reputación, sin afirmar infección. Fuentes: capturas/F001-virustotal-detecciones.jpg; capturas/F002-virustotal-detecciones.jpg; archivos-reputacion.json. https://www.virustotal.com/gui/file/6f9f663f832a06474913ec6bb0f94e3cca6e0658396a68053ff36abedbb050ba y https://www.virustotal.com/gui/file/06af7db1507c685154f7a291c862b0bfe5649c989de4e7acbeff23fd3252e4ec</a:t>
+              <a:t>0:00–1:30 (90 s). Propuesta: Benetucci Ignacio. Introducción (15 s): siete recursos, análisis estático, nunca ejecutamos muestras. F001 es una DLL aunque el nombre histórico termine en .exe; F002 es un ejecutable. Verificamos SHA-256, SHA-1, MD5 y tamaño contra VT: 47 detecciones cada uno. RAT significa troyano de acceso remoto; un atacante podría acceder a información o alterar el equipo, pero no observamos esas acciones. ValleyRAT viene de motores y reportes de terceros. Conclusión: maliciosos con confianza alta en reputación, sin afirmar infección. Fuentes: capturas/F001-virustotal-detecciones.jpg; capturas/F002-virustotal-detecciones.jpg; archivos-reputacion.json. https://www.virustotal.com/gui/file/6f9f663f832a06474913ec6bb0f94e3cca6e0658396a68053ff36abedbb050ba y https://www.virustotal.com/gui/file/06af7db1507c685154f7a291c862b0bfe5649c989de4e7acbeff23fd3252e4ec Medida: conservar aislado y bloquear hashes confirmados. Confidencialidad e integridad en riesgo potencial, sin infección acreditada.</a:t>
             </a:r>
           </a:p>
         </p:txBody>
@@ -517,7 +517,7 @@
           <a:lstStyle xmlns:a="http://schemas.openxmlformats.org/drawingml/2006/main"/>
           <a:p xmlns:a="http://schemas.openxmlformats.org/drawingml/2006/main">
             <a:r>
-              <a:t>1:30–2:50 (80 s). Propuesta: Maurel Garcete Philippe. R004 anuncia un producto para aliviar dolor de rodilla. Tiene cero adjuntos, dos enlaces acortados y un píxel remoto de seguimiento. El aporte del informe independiente permitió revisar pnreap.com: verificamos 12 motores maliciosos y uno sospechoso sobre la URL exacta. Por eso clasificamos el mensaje como malicioso por el contenido remoto que incorpora, con confianza media. Las cabeceras declaran SPF y DMARC pass; autenticar el dominio no prueba que el contenido sea seguro. No afirmamos robo de credenciales ni infección. No cargamos el píxel. Fuente: capturas/R004-pnreap-verificado.jpg; consolidacion/pnreap-verificacion.json; correos-html-resumen.json; Correo-1.txt y PDF aportado, p.16. https://www.virustotal.com/gui/url/b5964327810a7c813ae6a17ec150228e0f3c1bc77fa5dba775f7eaae5eda674d</a:t>
+              <a:t>1:30–2:50 (80 s). Propuesta: Maurel Garcete Philippe. R004 anuncia un producto para aliviar dolor de rodilla. Tiene cero adjuntos, dos enlaces acortados y un píxel remoto de seguimiento. La URL exacta de pnreap.com registra 12 motores maliciosos y uno sospechoso en VirusTotal. Por eso clasificamos el mensaje como malicioso por el contenido remoto que incorpora, con confianza media. Las cabeceras declaran SPF y DMARC pass; autenticar el dominio no prueba que el contenido sea seguro. No afirmamos robo de credenciales ni infección. No cargamos el píxel. Fuente: capturas/R004-pnreap-verificado.jpg; cierre/R004-pnreap-verificacion.json; correos-html-resumen.json. https://www.virustotal.com/gui/url/b5964327810a7c813ae6a17ec150228e0f3c1bc77fa5dba775f7eaae5eda674d Medida: evitar carga remota de imágenes y filtrar mensajes similares.</a:t>
             </a:r>
           </a:p>
         </p:txBody>
@@ -587,7 +587,7 @@
           <a:lstStyle xmlns:a="http://schemas.openxmlformats.org/drawingml/2006/main"/>
           <a:p xmlns:a="http://schemas.openxmlformats.org/drawingml/2006/main">
             <a:r>
-              <a:t>2:50–3:55 (65 s). Propuesta: Maurel Garcete Philippe. El mensaje ofrece bolas de Plinko y premios. El contenido tiene tres enlaces de acción y un píxel en woondsplay.com. El dominio registra siete motores maliciosos y dos sospechosos. Las URLs exactas consultadas no aportan un informe concluyente: no trasladamos automáticamente la clasificación del dominio al mensaje. Las cabeceras declaran SPF none, DMARC none y una firma DKIM cuyo dominio no está alineado con From. None no significa fail. Amenaza posible: spam o engaño mediante enlaces; no hay un malware adjunto identificado. Conclusión: sospechoso, confianza media. Fuentes: capturas/R005-dominio-enlaces-virustotal.jpg, correos-estaticos.json, correos-html-resumen.json y Correo-2.txt. https://www.virustotal.com/gui/domain/woondsplay.com</a:t>
+              <a:t>2:50–3:55 (65 s). Propuesta: Maurel Garcete Philippe. El mensaje ofrece bolas de Plinko y premios. El contenido tiene tres enlaces de acción y un píxel en woondsplay.com. El dominio registra siete motores maliciosos y dos sospechosos. Las URLs exactas consultadas no aportan un informe concluyente: no trasladamos automáticamente la clasificación del dominio al mensaje. Las cabeceras declaran SPF none, DMARC none y una firma DKIM cuyo dominio no está alineado con From. None no significa fail. Amenaza posible: spam o engaño mediante enlaces; no hay un malware adjunto identificado. Conclusión: sospechoso, confianza media. Fuentes: capturas/R005-dominio-enlaces-virustotal.jpg, correos-estaticos.json, correos-html-resumen.json. https://www.virustotal.com/gui/domain/woondsplay.com Medida: reportar como sospechoso y evitar enlaces. Posible seguimiento; integridad y disponibilidad sin efecto observado.</a:t>
             </a:r>
           </a:p>
         </p:txBody>
@@ -657,7 +657,7 @@
           <a:lstStyle xmlns:a="http://schemas.openxmlformats.org/drawingml/2006/main"/>
           <a:p xmlns:a="http://schemas.openxmlformats.org/drawingml/2006/main">
             <a:r>
-              <a:t>3:55–5:00 (65 s). Propuesta: Rodas Sebastián. URL g-comeceseuatendimenton.shop. El reporte exacto de urlscan del 16 de octubre muestra una página de orientación financiera sobre CPF, con cuenta regresiva y llamada a la acción. Hay un enlace saliente a feiraoaberto.netlify.app/login/; no lo seguimos ni lo describimos como redirección automática. VT tiene dos alertas. urlscan ofrece señales contradictorias: el motor ML alerta pero el veredicto global no confirma malicia. Riesgo posible de ingeniería social; no se observó formulario de credenciales. Conclusión: sospechoso. Fuente: capturas/U001-urlscan-imagen-archivada.jpg y U001-virustotal-url.jpg; urls/20261023T180740Z/U001.json. https://urlscan.io/result/01a1462b-bbda-773d-a9b2-fa0511ed4b52/</a:t>
+              <a:t>3:55–5:00 (65 s). Propuesta: Rodas Sebastián. URL g-comeceseuatendimenton.shop. El reporte exacto de urlscan del 16 de octubre muestra una página de orientación financiera sobre CPF, con cuenta regresiva y llamada a la acción. Hay un enlace saliente a feiraoaberto.netlify.app/login/; no lo seguimos ni lo describimos como redirección automática. VT tiene dos alertas. urlscan ofrece señales contradictorias: el motor ML alerta pero el veredicto global no confirma malicia. Riesgo posible de ingeniería social; no se observó formulario de credenciales. Conclusión: sospechoso. Fuente: capturas/U001-urlscan-imagen-archivada.jpg y U001-virustotal-url.jpg; urls/20261023T180740Z/U001.json. https://urlscan.io/result/01a1462b-bbda-773d-a9b2-fa0511ed4b52/ Medida: verificar por canal oficial independiente. Confidencialidad en riesgo potencial; sin impacto demostrado en integridad y disponibilidad.</a:t>
             </a:r>
           </a:p>
         </p:txBody>
@@ -727,7 +727,7 @@
           <a:lstStyle xmlns:a="http://schemas.openxmlformats.org/drawingml/2006/main"/>
           <a:p xmlns:a="http://schemas.openxmlformats.org/drawingml/2006/main">
             <a:r>
-              <a:t>5:00–6:50 (110 s). Propuesta: Sánchez Franco. Este caso conecta dos herramientas. En urlscan, mostrar el registro de descarga: ELF de 32 bits para MIPS, 137480 bytes. No es un script aunque la ruta termine en .sh. Copiar solo el hash visible y mostrar el informe ya existente de VT: mismo SHA-256 y tamaño, 50 motores maliciosos. Reservar unos 35 segundos de este bloque para recorrer ambos informes; si falla Internet, usar estas capturas. Nunca abrir el destino ni pulsar Reanalyze ni descargar el archivo. SHA-256 f6c97b1e2ed02578ca1066c8235ba4f991e645f89012406c639dbccc6582eec8. Motores etiquetan Mirai/Mozi, asociados a botnets y DDoS; es atribución de terceros, no comportamiento ejecutado por nosotros. Conclusión: malicioso con confianza alta en asociación histórica y reputación. Fuentes: capturas/U002-urlscan-descarga-detalle.jpg; U002-virustotal-hash-descarga.jpg. https://urlscan.io/result/01a1464c-f4e2-70ba-8c0c-131c9851a684/ y https://www.virustotal.com/gui/file/f6c97b1e2ed02578ca1066c8235ba4f991e645f89012406c639dbccc6582eec8</a:t>
+              <a:t>5:00–6:50 (110 s). Propuesta: Sánchez Franco. Este caso conecta dos herramientas. En urlscan, mostrar el registro de descarga: ELF de 32 bits para MIPS, 137480 bytes. No es un script aunque la ruta termine en .sh. Copiar solo el hash visible y mostrar el informe ya existente de VT: mismo SHA-256 y tamaño, 50 motores maliciosos. Reservar 35 segundos para la demostración. Dejar abiertos antes de exponer los informes de urlscan y VirusTotal, accesibles desde los rótulos de esta diapositiva. En urlscan mostrar Downloads y su SHA-256; en VirusTotal mostrar el mismo hash y 50 detecciones. Si falla Internet, las capturas permiten explicar el caso, aunque no reemplazan el requisito de mostrar dos herramientas en vivo. Nunca abrir el destino ni pulsar Reanalyze ni descargar el archivo. SHA-256 f6c97b1e2ed02578ca1066c8235ba4f991e645f89012406c639dbccc6582eec8. Motores etiquetan Mirai/Mozi, asociados a botnets y DDoS; es atribución de terceros, no comportamiento ejecutado por nosotros. Conclusión: malicioso con confianza alta en asociación histórica y reputación. Fuentes: capturas/U002-urlscan-descarga-detalle.jpg; U002-virustotal-hash-descarga.jpg. https://urlscan.io/result/01a1464c-f4e2-70ba-8c0c-131c9851a684/ y https://www.virustotal.com/gui/file/f6c97b1e2ed02578ca1066c8235ba4f991e645f89012406c639dbccc6582eec8</a:t>
             </a:r>
           </a:p>
         </p:txBody>
@@ -3240,12 +3240,12 @@
   </p:cSld>
   <p:clrMap bg1="lt1" tx1="dk1" bg2="lt2" tx2="dk2" accent1="accent1" accent2="accent2" accent3="accent3" accent4="accent4" accent5="accent5" accent6="accent6" hlink="hlink" folHlink="folHlink"/>
   <p:sldLayoutIdLst>
-    <p:sldLayoutId xmlns:r="http://schemas.openxmlformats.org/officeDocument/2006/relationships" id="2147483649" r:id="R7d597c7fc9624790"/>
-    <p:sldLayoutId xmlns:r="http://schemas.openxmlformats.org/officeDocument/2006/relationships" id="2147483650" r:id="Red2e5bd2a4bf4e99"/>
-    <p:sldLayoutId xmlns:r="http://schemas.openxmlformats.org/officeDocument/2006/relationships" id="2147483651" r:id="R12104a75964f4e9d"/>
-    <p:sldLayoutId xmlns:r="http://schemas.openxmlformats.org/officeDocument/2006/relationships" id="2147483652" r:id="Ra1ed616942a3464d"/>
-    <p:sldLayoutId xmlns:r="http://schemas.openxmlformats.org/officeDocument/2006/relationships" id="2147483653" r:id="R581d94a1f31049d6"/>
-    <p:sldLayoutId xmlns:r="http://schemas.openxmlformats.org/officeDocument/2006/relationships" id="2147483654" r:id="R29272609595d4e12"/>
+    <p:sldLayoutId xmlns:r="http://schemas.openxmlformats.org/officeDocument/2006/relationships" id="2147483649" r:id="Re4d8f6d444a248c6"/>
+    <p:sldLayoutId xmlns:r="http://schemas.openxmlformats.org/officeDocument/2006/relationships" id="2147483650" r:id="R5b78f6121dd74be7"/>
+    <p:sldLayoutId xmlns:r="http://schemas.openxmlformats.org/officeDocument/2006/relationships" id="2147483651" r:id="R38180dbe6a4d4fb3"/>
+    <p:sldLayoutId xmlns:r="http://schemas.openxmlformats.org/officeDocument/2006/relationships" id="2147483652" r:id="Rf342adcebe054220"/>
+    <p:sldLayoutId xmlns:r="http://schemas.openxmlformats.org/officeDocument/2006/relationships" id="2147483653" r:id="R9bc41c59ca324bae"/>
+    <p:sldLayoutId xmlns:r="http://schemas.openxmlformats.org/officeDocument/2006/relationships" id="2147483654" r:id="Rb26fbb0457414fca"/>
   </p:sldLayoutIdLst>
   <p:txStyles>
     <p:titleStyle>
@@ -4286,7 +4286,7 @@
           <p:nvPr/>
         </p:nvPicPr>
         <p:blipFill>
-          <a:blip xmlns:r="http://schemas.openxmlformats.org/officeDocument/2006/relationships" xmlns:a="http://schemas.openxmlformats.org/drawingml/2006/main" r:embed="Rcd17ef6255c542f1"/>
+          <a:blip xmlns:r="http://schemas.openxmlformats.org/officeDocument/2006/relationships" xmlns:a="http://schemas.openxmlformats.org/drawingml/2006/main" r:embed="R50cfd3af9efc4f0e"/>
           <a:stretch xmlns:a="http://schemas.openxmlformats.org/drawingml/2006/main"/>
         </p:blipFill>
         <p:spPr>
@@ -4314,7 +4314,7 @@
           <p:nvPr/>
         </p:nvPicPr>
         <p:blipFill>
-          <a:blip xmlns:r="http://schemas.openxmlformats.org/officeDocument/2006/relationships" xmlns:a="http://schemas.openxmlformats.org/drawingml/2006/main" r:embed="R4be5759d21264fff"/>
+          <a:blip xmlns:r="http://schemas.openxmlformats.org/officeDocument/2006/relationships" xmlns:a="http://schemas.openxmlformats.org/drawingml/2006/main" r:embed="R2406e4b8608c45f6"/>
           <a:stretch xmlns:a="http://schemas.openxmlformats.org/drawingml/2006/main"/>
         </p:blipFill>
         <p:spPr>
@@ -4437,10 +4437,11 @@
               </a:defRPr>
             </a:pPr>
             <a:r>
-              <a:rPr sz="1875" b="1">
-                <a:solidFill>
-                  <a:srgbClr val="13263E"/>
-                </a:solidFill>
+              <a:rPr sz="1875" b="1" u="sng">
+                <a:solidFill>
+                  <a:srgbClr val="13263E"/>
+                </a:solidFill>
+                <a:hlinkClick xmlns:ns0="http://schemas.openxmlformats.org/officeDocument/2006/relationships" ns0:id="rIdLink1"/>
               </a:rPr>
               <a:t>F001 · DLL x64 · 47 detecciones</a:t>
             </a:r>
@@ -4557,10 +4558,11 @@
               </a:defRPr>
             </a:pPr>
             <a:r>
-              <a:rPr sz="1875" b="1">
-                <a:solidFill>
-                  <a:srgbClr val="13263E"/>
-                </a:solidFill>
+              <a:rPr sz="1875" b="1" u="sng">
+                <a:solidFill>
+                  <a:srgbClr val="13263E"/>
+                </a:solidFill>
+                <a:hlinkClick xmlns:ns1="http://schemas.openxmlformats.org/officeDocument/2006/relationships" ns1:id="rIdLink2"/>
               </a:rPr>
               <a:t>F002 · EXE x64 · 47 detecciones</a:t>
             </a:r>
@@ -5348,7 +5350,7 @@
           <p:nvPr/>
         </p:nvPicPr>
         <p:blipFill>
-          <a:blip xmlns:r="http://schemas.openxmlformats.org/officeDocument/2006/relationships" xmlns:a="http://schemas.openxmlformats.org/drawingml/2006/main" r:embed="Rbad905d6851d4f79"/>
+          <a:blip xmlns:r="http://schemas.openxmlformats.org/officeDocument/2006/relationships" xmlns:a="http://schemas.openxmlformats.org/drawingml/2006/main" r:embed="R442274c221b8498d"/>
           <a:stretch xmlns:a="http://schemas.openxmlformats.org/drawingml/2006/main"/>
         </p:blipFill>
         <p:spPr>
@@ -5755,10 +5757,11 @@
               </a:defRPr>
             </a:pPr>
             <a:r>
-              <a:rPr sz="1200" b="0">
-                <a:solidFill>
-                  <a:srgbClr val="51627A"/>
-                </a:solidFill>
+              <a:rPr sz="1200" b="0" u="sng">
+                <a:solidFill>
+                  <a:srgbClr val="51627A"/>
+                </a:solidFill>
+                <a:hlinkClick xmlns:ns0="http://schemas.openxmlformats.org/officeDocument/2006/relationships" ns0:id="rIdLink3"/>
               </a:rPr>
               <a:t>VirusTotal · URL exacta corroborada el 23/10/2026. El correo no contiene adjuntos.</a:t>
             </a:r>
@@ -6289,7 +6292,7 @@
           <p:nvPr/>
         </p:nvPicPr>
         <p:blipFill>
-          <a:blip xmlns:r="http://schemas.openxmlformats.org/officeDocument/2006/relationships" xmlns:a="http://schemas.openxmlformats.org/drawingml/2006/main" r:embed="R590a239d6af14ca7"/>
+          <a:blip xmlns:r="http://schemas.openxmlformats.org/officeDocument/2006/relationships" xmlns:a="http://schemas.openxmlformats.org/drawingml/2006/main" r:embed="R449eeb4dc4f443c9"/>
           <a:stretch xmlns:a="http://schemas.openxmlformats.org/drawingml/2006/main"/>
         </p:blipFill>
         <p:spPr>
@@ -6713,10 +6716,11 @@
               </a:defRPr>
             </a:pPr>
             <a:r>
-              <a:rPr sz="1200" b="0">
-                <a:solidFill>
-                  <a:srgbClr val="51627A"/>
-                </a:solidFill>
+              <a:rPr sz="1200" b="0" u="sng">
+                <a:solidFill>
+                  <a:srgbClr val="51627A"/>
+                </a:solidFill>
+                <a:hlinkClick xmlns:ns0="http://schemas.openxmlformats.org/officeDocument/2006/relationships" ns0:id="rIdLink4"/>
               </a:rPr>
               <a:t>VirusTotal · Reputación del dominio. No equivale al veredicto de cada URL.</a:t>
             </a:r>
@@ -7247,7 +7251,7 @@
           <p:nvPr/>
         </p:nvPicPr>
         <p:blipFill>
-          <a:blip xmlns:r="http://schemas.openxmlformats.org/officeDocument/2006/relationships" xmlns:a="http://schemas.openxmlformats.org/drawingml/2006/main" r:embed="R8248d8f94ccf4dc8"/>
+          <a:blip xmlns:r="http://schemas.openxmlformats.org/officeDocument/2006/relationships" xmlns:a="http://schemas.openxmlformats.org/drawingml/2006/main" r:embed="R4f64ffa7a3844b0b"/>
           <a:stretch xmlns:a="http://schemas.openxmlformats.org/drawingml/2006/main"/>
         </p:blipFill>
         <p:spPr>
@@ -7370,10 +7374,11 @@
               </a:defRPr>
             </a:pPr>
             <a:r>
-              <a:rPr sz="2325" b="1">
+              <a:rPr sz="2325" b="1" u="sng">
                 <a:solidFill>
                   <a:srgbClr val="996100"/>
                 </a:solidFill>
+                <a:hlinkClick xmlns:ns0="http://schemas.openxmlformats.org/officeDocument/2006/relationships" ns0:id="rIdLink5"/>
               </a:rPr>
               <a:t>2 alertas en la URL</a:t>
             </a:r>
@@ -7654,10 +7659,11 @@
               </a:defRPr>
             </a:pPr>
             <a:r>
-              <a:rPr sz="1200" b="0">
-                <a:solidFill>
-                  <a:srgbClr val="51627A"/>
-                </a:solidFill>
+              <a:rPr sz="1200" b="0" u="sng">
+                <a:solidFill>
+                  <a:srgbClr val="51627A"/>
+                </a:solidFill>
+                <a:hlinkClick xmlns:ns1="http://schemas.openxmlformats.org/officeDocument/2006/relationships" ns1:id="rIdLink6"/>
               </a:rPr>
               <a:t>urlscan · Captura histórica del 16/10/2026. Dominio: g-comeceseuatendimenton[.]shop</a:t>
             </a:r>
@@ -8188,7 +8194,7 @@
           <p:nvPr/>
         </p:nvPicPr>
         <p:blipFill>
-          <a:blip xmlns:r="http://schemas.openxmlformats.org/officeDocument/2006/relationships" xmlns:a="http://schemas.openxmlformats.org/drawingml/2006/main" r:embed="Rf54b2f77d5f246a7"/>
+          <a:blip xmlns:r="http://schemas.openxmlformats.org/officeDocument/2006/relationships" xmlns:a="http://schemas.openxmlformats.org/drawingml/2006/main" r:embed="Rc407ae9630524861"/>
           <a:stretch xmlns:a="http://schemas.openxmlformats.org/drawingml/2006/main"/>
         </p:blipFill>
         <p:spPr>
@@ -8216,7 +8222,7 @@
           <p:nvPr/>
         </p:nvPicPr>
         <p:blipFill>
-          <a:blip xmlns:r="http://schemas.openxmlformats.org/officeDocument/2006/relationships" xmlns:a="http://schemas.openxmlformats.org/drawingml/2006/main" r:embed="R3943c0a419984894"/>
+          <a:blip xmlns:r="http://schemas.openxmlformats.org/officeDocument/2006/relationships" xmlns:a="http://schemas.openxmlformats.org/drawingml/2006/main" r:embed="R53da5734fdc64230"/>
           <a:stretch xmlns:a="http://schemas.openxmlformats.org/drawingml/2006/main"/>
         </p:blipFill>
         <p:spPr>
@@ -8339,10 +8345,11 @@
               </a:defRPr>
             </a:pPr>
             <a:r>
-              <a:rPr sz="1950" b="1">
-                <a:solidFill>
-                  <a:srgbClr val="13263E"/>
-                </a:solidFill>
+              <a:rPr sz="1950" b="1" u="sng">
+                <a:solidFill>
+                  <a:srgbClr val="13263E"/>
+                </a:solidFill>
+                <a:hlinkClick xmlns:ns0="http://schemas.openxmlformats.org/officeDocument/2006/relationships" ns0:id="rIdLink7"/>
               </a:rPr>
               <a:t>urlscan · ELF de 137.480 bytes</a:t>
             </a:r>
@@ -8459,10 +8466,11 @@
               </a:defRPr>
             </a:pPr>
             <a:r>
-              <a:rPr sz="1950" b="1">
-                <a:solidFill>
-                  <a:srgbClr val="13263E"/>
-                </a:solidFill>
+              <a:rPr sz="1950" b="1" u="sng">
+                <a:solidFill>
+                  <a:srgbClr val="13263E"/>
+                </a:solidFill>
+                <a:hlinkClick xmlns:ns1="http://schemas.openxmlformats.org/officeDocument/2006/relationships" ns1:id="rIdLink8"/>
               </a:rPr>
               <a:t>VirusTotal · 50 detecciones</a:t>
             </a:r>
@@ -9250,7 +9258,7 @@
           <p:nvPr/>
         </p:nvPicPr>
         <p:blipFill>
-          <a:blip xmlns:r="http://schemas.openxmlformats.org/officeDocument/2006/relationships" xmlns:a="http://schemas.openxmlformats.org/drawingml/2006/main" r:embed="R9c3479e35d79448e"/>
+          <a:blip xmlns:r="http://schemas.openxmlformats.org/officeDocument/2006/relationships" xmlns:a="http://schemas.openxmlformats.org/drawingml/2006/main" r:embed="Rb952315e47ff49a0"/>
           <a:stretch xmlns:a="http://schemas.openxmlformats.org/drawingml/2006/main"/>
         </p:blipFill>
         <p:spPr>
@@ -9280,7 +9288,7 @@
         <p:spPr>
           <a:xfrm xmlns:a="http://schemas.openxmlformats.org/drawingml/2006/main">
             <a:off x="8382000" y="1857375"/>
-            <a:ext cx="3333750" cy="857250"/>
+            <a:ext cx="3333750" cy="1095375"/>
           </a:xfrm>
           <a:prstGeom xmlns:a="http://schemas.openxmlformats.org/drawingml/2006/main" prst="rect">
             <a:avLst/>
@@ -9294,70 +9302,70 @@
           <a:bodyPr xmlns:a="http://schemas.openxmlformats.org/drawingml/2006/main"/>
           <a:lstStyle xmlns:a="http://schemas.openxmlformats.org/drawingml/2006/main">
             <a:defPPr>
-              <a:defRPr sz="2250" b="1">
+              <a:defRPr sz="2100" b="1">
                 <a:solidFill>
                   <a:srgbClr val="996100"/>
                 </a:solidFill>
               </a:defRPr>
             </a:defPPr>
             <a:lvl1pPr>
-              <a:defRPr sz="2250" b="1">
+              <a:defRPr sz="2100" b="1">
                 <a:solidFill>
                   <a:srgbClr val="996100"/>
                 </a:solidFill>
               </a:defRPr>
             </a:lvl1pPr>
             <a:lvl2pPr>
-              <a:defRPr sz="2250" b="1">
+              <a:defRPr sz="2100" b="1">
                 <a:solidFill>
                   <a:srgbClr val="996100"/>
                 </a:solidFill>
               </a:defRPr>
             </a:lvl2pPr>
             <a:lvl3pPr>
-              <a:defRPr sz="2250" b="1">
+              <a:defRPr sz="2100" b="1">
                 <a:solidFill>
                   <a:srgbClr val="996100"/>
                 </a:solidFill>
               </a:defRPr>
             </a:lvl3pPr>
             <a:lvl4pPr>
-              <a:defRPr sz="2250" b="1">
+              <a:defRPr sz="2100" b="1">
                 <a:solidFill>
                   <a:srgbClr val="996100"/>
                 </a:solidFill>
               </a:defRPr>
             </a:lvl4pPr>
             <a:lvl5pPr>
-              <a:defRPr sz="2250" b="1">
+              <a:defRPr sz="2100" b="1">
                 <a:solidFill>
                   <a:srgbClr val="996100"/>
                 </a:solidFill>
               </a:defRPr>
             </a:lvl5pPr>
             <a:lvl6pPr>
-              <a:defRPr sz="2250" b="1">
+              <a:defRPr sz="2100" b="1">
                 <a:solidFill>
                   <a:srgbClr val="996100"/>
                 </a:solidFill>
               </a:defRPr>
             </a:lvl6pPr>
             <a:lvl7pPr>
-              <a:defRPr sz="2250" b="1">
+              <a:defRPr sz="2100" b="1">
                 <a:solidFill>
                   <a:srgbClr val="996100"/>
                 </a:solidFill>
               </a:defRPr>
             </a:lvl7pPr>
             <a:lvl8pPr>
-              <a:defRPr sz="2250" b="1">
+              <a:defRPr sz="2100" b="1">
                 <a:solidFill>
                   <a:srgbClr val="996100"/>
                 </a:solidFill>
               </a:defRPr>
             </a:lvl8pPr>
             <a:lvl9pPr>
-              <a:defRPr sz="2250" b="1">
+              <a:defRPr sz="2100" b="1">
                 <a:solidFill>
                   <a:srgbClr val="996100"/>
                 </a:solidFill>
@@ -9366,36 +9374,56 @@
           </a:lstStyle>
           <a:p xmlns:a="http://schemas.openxmlformats.org/drawingml/2006/main">
             <a:pPr>
-              <a:defRPr sz="2250" b="1">
+              <a:defRPr sz="2100" b="1">
                 <a:solidFill>
                   <a:srgbClr val="996100"/>
                 </a:solidFill>
               </a:defRPr>
             </a:pPr>
             <a:r>
-              <a:rPr sz="2250" b="1">
+              <a:rPr sz="2100" b="1" u="sng">
                 <a:solidFill>
                   <a:srgbClr val="996100"/>
                 </a:solidFill>
+                <a:hlinkClick xmlns:ns0="http://schemas.openxmlformats.org/officeDocument/2006/relationships" ns0:id="rIdLink9"/>
               </a:rPr>
-              <a:t>URL: 1 malicioso</a:t>
+              <a:t>URL: 1 detección</a:t>
             </a:r>
           </a:p>
           <a:p xmlns:a="http://schemas.openxmlformats.org/drawingml/2006/main">
             <a:pPr>
-              <a:defRPr sz="2250" b="1">
+              <a:defRPr sz="2100" b="1">
                 <a:solidFill>
                   <a:srgbClr val="996100"/>
                 </a:solidFill>
               </a:defRPr>
             </a:pPr>
             <a:r>
-              <a:rPr sz="2250" b="1">
+              <a:rPr sz="2100" b="1" u="sng">
                 <a:solidFill>
                   <a:srgbClr val="996100"/>
                 </a:solidFill>
+                <a:hlinkClick xmlns:ns1="http://schemas.openxmlformats.org/officeDocument/2006/relationships" ns1:id="rIdLink10"/>
               </a:rPr>
-              <a:t>Dominio: 6 + 2</a:t>
+              <a:t>Dominio: 6 maliciosos</a:t>
+            </a:r>
+          </a:p>
+          <a:p xmlns:a="http://schemas.openxmlformats.org/drawingml/2006/main">
+            <a:pPr>
+              <a:defRPr sz="2100" b="1">
+                <a:solidFill>
+                  <a:srgbClr val="996100"/>
+                </a:solidFill>
+              </a:defRPr>
+            </a:pPr>
+            <a:r>
+              <a:rPr sz="2100" b="1" u="sng">
+                <a:solidFill>
+                  <a:srgbClr val="996100"/>
+                </a:solidFill>
+                <a:hlinkClick xmlns:ns2="http://schemas.openxmlformats.org/officeDocument/2006/relationships" ns2:id="rIdLink11"/>
+              </a:rPr>
+              <a:t>+ 2 sospechosos</a:t>
             </a:r>
           </a:p>
         </p:txBody>
@@ -9416,8 +9444,8 @@
         </p:nvSpPr>
         <p:spPr>
           <a:xfrm xmlns:a="http://schemas.openxmlformats.org/drawingml/2006/main">
-            <a:off x="8382000" y="2952750"/>
-            <a:ext cx="3333750" cy="2857500"/>
+            <a:off x="8382000" y="3143250"/>
+            <a:ext cx="3333750" cy="2619375"/>
           </a:xfrm>
           <a:prstGeom xmlns:a="http://schemas.openxmlformats.org/drawingml/2006/main" prst="rect">
             <a:avLst/>
@@ -9431,70 +9459,70 @@
           <a:bodyPr xmlns:a="http://schemas.openxmlformats.org/drawingml/2006/main"/>
           <a:lstStyle xmlns:a="http://schemas.openxmlformats.org/drawingml/2006/main">
             <a:defPPr>
-              <a:defRPr sz="1950" b="0">
+              <a:defRPr sz="1875" b="0">
                 <a:solidFill>
                   <a:srgbClr val="13263E"/>
                 </a:solidFill>
               </a:defRPr>
             </a:defPPr>
             <a:lvl1pPr>
-              <a:defRPr sz="1950" b="0">
+              <a:defRPr sz="1875" b="0">
                 <a:solidFill>
                   <a:srgbClr val="13263E"/>
                 </a:solidFill>
               </a:defRPr>
             </a:lvl1pPr>
             <a:lvl2pPr>
-              <a:defRPr sz="1950" b="0">
+              <a:defRPr sz="1875" b="0">
                 <a:solidFill>
                   <a:srgbClr val="13263E"/>
                 </a:solidFill>
               </a:defRPr>
             </a:lvl2pPr>
             <a:lvl3pPr>
-              <a:defRPr sz="1950" b="0">
+              <a:defRPr sz="1875" b="0">
                 <a:solidFill>
                   <a:srgbClr val="13263E"/>
                 </a:solidFill>
               </a:defRPr>
             </a:lvl3pPr>
             <a:lvl4pPr>
-              <a:defRPr sz="1950" b="0">
+              <a:defRPr sz="1875" b="0">
                 <a:solidFill>
                   <a:srgbClr val="13263E"/>
                 </a:solidFill>
               </a:defRPr>
             </a:lvl4pPr>
             <a:lvl5pPr>
-              <a:defRPr sz="1950" b="0">
+              <a:defRPr sz="1875" b="0">
                 <a:solidFill>
                   <a:srgbClr val="13263E"/>
                 </a:solidFill>
               </a:defRPr>
             </a:lvl5pPr>
             <a:lvl6pPr>
-              <a:defRPr sz="1950" b="0">
+              <a:defRPr sz="1875" b="0">
                 <a:solidFill>
                   <a:srgbClr val="13263E"/>
                 </a:solidFill>
               </a:defRPr>
             </a:lvl6pPr>
             <a:lvl7pPr>
-              <a:defRPr sz="1950" b="0">
+              <a:defRPr sz="1875" b="0">
                 <a:solidFill>
                   <a:srgbClr val="13263E"/>
                 </a:solidFill>
               </a:defRPr>
             </a:lvl7pPr>
             <a:lvl8pPr>
-              <a:defRPr sz="1950" b="0">
+              <a:defRPr sz="1875" b="0">
                 <a:solidFill>
                   <a:srgbClr val="13263E"/>
                 </a:solidFill>
               </a:defRPr>
             </a:lvl8pPr>
             <a:lvl9pPr>
-              <a:defRPr sz="1950" b="0">
+              <a:defRPr sz="1875" b="0">
                 <a:solidFill>
                   <a:srgbClr val="13263E"/>
                 </a:solidFill>
@@ -9503,14 +9531,14 @@
           </a:lstStyle>
           <a:p xmlns:a="http://schemas.openxmlformats.org/drawingml/2006/main">
             <a:pPr>
-              <a:defRPr sz="1950" b="0">
+              <a:defRPr sz="1875" b="0">
                 <a:solidFill>
                   <a:srgbClr val="13263E"/>
                 </a:solidFill>
               </a:defRPr>
             </a:pPr>
             <a:r>
-              <a:rPr sz="1950" b="0">
+              <a:rPr sz="1875" b="0">
                 <a:solidFill>
                   <a:srgbClr val="13263E"/>
                 </a:solidFill>
@@ -9519,47 +9547,61 @@
             </a:r>
           </a:p>
           <a:p xmlns:a="http://schemas.openxmlformats.org/drawingml/2006/main">
+            <a:pPr>
+              <a:defRPr sz="1950" b="0">
+                <a:solidFill>
+                  <a:srgbClr val="13263E"/>
+                </a:solidFill>
+              </a:defRPr>
+            </a:pPr>
             <a:r>
               <a:t/>
             </a:r>
           </a:p>
           <a:p xmlns:a="http://schemas.openxmlformats.org/drawingml/2006/main">
             <a:pPr>
-              <a:defRPr sz="1950" b="0">
+              <a:defRPr sz="1875" b="0">
                 <a:solidFill>
                   <a:srgbClr val="13263E"/>
                 </a:solidFill>
               </a:defRPr>
             </a:pPr>
             <a:r>
-              <a:rPr sz="1950" b="0">
+              <a:rPr sz="1875" b="0">
                 <a:solidFill>
                   <a:srgbClr val="13263E"/>
                 </a:solidFill>
               </a:rPr>
-              <a:t>Sin tienda fraudulenta ni formulario acreditados.</a:t>
+              <a:t>Sin tienda ni formulario de credenciales observados.</a:t>
             </a:r>
           </a:p>
           <a:p xmlns:a="http://schemas.openxmlformats.org/drawingml/2006/main">
+            <a:pPr>
+              <a:defRPr sz="1950" b="0">
+                <a:solidFill>
+                  <a:srgbClr val="13263E"/>
+                </a:solidFill>
+              </a:defRPr>
+            </a:pPr>
             <a:r>
               <a:t/>
             </a:r>
           </a:p>
           <a:p xmlns:a="http://schemas.openxmlformats.org/drawingml/2006/main">
             <a:pPr>
-              <a:defRPr sz="1950" b="0">
+              <a:defRPr sz="1875" b="0">
                 <a:solidFill>
                   <a:srgbClr val="13263E"/>
                 </a:solidFill>
               </a:defRPr>
             </a:pPr>
             <a:r>
-              <a:rPr sz="1950" b="0">
+              <a:rPr sz="1875" b="0">
                 <a:solidFill>
                   <a:srgbClr val="13263E"/>
                 </a:solidFill>
               </a:rPr>
-              <a:t>Amenaza posible: engaño por apariencia de dominio.</a:t>
+              <a:t>Riesgo posible de engaño; fraude sin confirmar.</a:t>
             </a:r>
           </a:p>
         </p:txBody>
@@ -9794,10 +9836,11 @@
               </a:defRPr>
             </a:pPr>
             <a:r>
-              <a:rPr sz="1200" b="0">
-                <a:solidFill>
-                  <a:srgbClr val="51627A"/>
-                </a:solidFill>
+              <a:rPr sz="1200" b="0" u="sng">
+                <a:solidFill>
+                  <a:srgbClr val="51627A"/>
+                </a:solidFill>
+                <a:hlinkClick xmlns:ns3="http://schemas.openxmlformats.org/officeDocument/2006/relationships" ns3:id="rIdLink12"/>
               </a:rPr>
               <a:t>urlscan · Histórico del 16/10/2026. www[.]pneustorebr[.]cfd · “Sin detección” no significa limpio.</a:t>
             </a:r>

</xml_diff>